<commit_message>
Venezuela deck: review fixes (forecast title says forecasts, legend, third ASAP dekad to month end, rank-1 guard, non-GeoTIFF guard, widescreen size and master so new slides match, chart axis, title length check)
Co-Authored-By: Claude Opus 5.5 <noreply@anthropic.com>
</commit_message>
<xml_diff>
--- a/docs/enso/ven/slides/venezuela-el-nino-2026-27.pptx
+++ b/docs/enso/ven/slides/venezuela-el-nino-2026-27.pptx
@@ -6,7 +6,7 @@
   </p:sldMasterIdLst>
   <p:sldIdLst>
     <p:sldId id="256" r:id="rId7"/>
-    <p:sldId id="257" r:id="rId8"/>
+    <p:sldId id="257" r:id="rId9"/>
     <p:sldId id="258" r:id="rId10"/>
     <p:sldId id="259" r:id="rId11"/>
     <p:sldId id="260" r:id="rId12"/>
@@ -16,7 +16,7 @@
     <p:sldId id="264" r:id="rId16"/>
     <p:sldId id="265" r:id="rId17"/>
   </p:sldIdLst>
-  <p:sldSz cx="12191695" cy="6858000" type="screen4x3"/>
+  <p:sldSz cx="12192000" cy="6858000"/>
   <p:notesSz cx="6858000" cy="9144000"/>
   <p:defaultTextStyle>
     <a:defPPr>
@@ -687,7 +687,77 @@
           <a:lstStyle/>
           <a:p>
             <a:r>
-              <a:t>One line for each part of the deck: what past El Niño years brought, how this year has gone, and what the forecast says. Past years are context; the forecast is what to plan on.</a:t>
+              <a:t>Three parts: what past El Niño years brought, how this year has gone so far, and the seasonal forecast for the coming months. For this season, plan on the forecast; past years are context.</a:t>
+            </a:r>
+          </a:p>
+        </p:txBody>
+      </p:sp>
+      <p:sp>
+        <p:nvSpPr>
+          <p:cNvPr id="4" name="Slide Number Placeholder 3"/>
+          <p:cNvSpPr>
+            <a:spLocks noGrp="1"/>
+          </p:cNvSpPr>
+          <p:nvPr>
+            <p:ph type="sldNum" idx="5" sz="quarter"/>
+          </p:nvPr>
+        </p:nvSpPr>
+        <p:spPr/>
+      </p:sp>
+    </p:spTree>
+  </p:cSld>
+  <p:clrMapOvr>
+    <a:masterClrMapping/>
+  </p:clrMapOvr>
+</p:notes>
+</file>
+
+<file path=ppt/notesSlides/notesSlide10.xml><?xml version="1.0" encoding="utf-8"?>
+<p:notes xmlns:a="http://schemas.openxmlformats.org/drawingml/2006/main" xmlns:p="http://schemas.openxmlformats.org/presentationml/2006/main" xmlns:r="http://schemas.openxmlformats.org/officeDocument/2006/relationships">
+  <p:cSld>
+    <p:spTree>
+      <p:nvGrpSpPr>
+        <p:cNvPr id="1" name=""/>
+        <p:cNvGrpSpPr/>
+        <p:nvPr/>
+      </p:nvGrpSpPr>
+      <p:grpSpPr>
+        <a:xfrm>
+          <a:off x="0" y="0"/>
+          <a:ext cx="0" cy="0"/>
+          <a:chOff x="0" y="0"/>
+          <a:chExt cx="0" cy="0"/>
+        </a:xfrm>
+      </p:grpSpPr>
+      <p:sp>
+        <p:nvSpPr>
+          <p:cNvPr id="2" name="Slide Image Placeholder 1"/>
+          <p:cNvSpPr>
+            <a:spLocks noGrp="1"/>
+          </p:cNvSpPr>
+          <p:nvPr>
+            <p:ph type="sldImg" idx="2"/>
+          </p:nvPr>
+        </p:nvSpPr>
+        <p:spPr/>
+      </p:sp>
+      <p:sp>
+        <p:nvSpPr>
+          <p:cNvPr id="3" name="Notes Placeholder 2"/>
+          <p:cNvSpPr>
+            <a:spLocks noGrp="1"/>
+          </p:cNvSpPr>
+          <p:nvPr>
+            <p:ph type="body" idx="3" sz="quarter"/>
+          </p:nvPr>
+        </p:nvSpPr>
+        <p:spPr/>
+        <p:txBody>
+          <a:bodyPr/>
+          <a:lstStyle/>
+          <a:p>
+            <a:r>
+              <a:t>Things that will change this picture over the coming weeks.</a:t>
             </a:r>
           </a:p>
         </p:txBody>
@@ -757,7 +827,7 @@
           <a:lstStyle/>
           <a:p>
             <a:r>
-              <a:t>INAMEH’s zones by rainy-season onset run from early April in the far south (A) to late June on the northern coast (E). Each zone’s rainy season runs from its onset to November; its dry season from December to the onset.</a:t>
+              <a:t>One line for each part of the deck: what past El Niño years brought, how this year has gone, and what the forecast says. Past years are context; the forecast is what to plan on.</a:t>
             </a:r>
           </a:p>
         </p:txBody>
@@ -827,7 +897,7 @@
           <a:lstStyle/>
           <a:p>
             <a:r>
-              <a:t>Floods: DesInventar records, each year against the years around it. Guri: NASA G-REALM satellite altimetry since 1992. Vegetation: JRC ASAP FPAR, November–April, since 2000; 2023/24, a strong El Niño, was not among the poorest.</a:t>
+              <a:t>INAMEH’s zones by rainy-season onset run from early April in the far south (A) to late June on the northern coast (E). Each zone’s rainy season runs from its onset to November; its dry season from December to the onset.</a:t>
             </a:r>
           </a:p>
         </p:txBody>
@@ -897,7 +967,7 @@
           <a:lstStyle/>
           <a:p>
             <a:r>
-              <a:t>Each region’s total for the months so far this rain year, as a share of its 1991–2020 normal.</a:t>
+              <a:t>Floods: DesInventar records, each year against the years around it. Guri: NASA G-REALM satellite altimetry since 1992. Vegetation: JRC ASAP FPAR, November–April, since 2000; 2023/24, a strong El Niño, was not among the poorest.</a:t>
             </a:r>
           </a:p>
         </p:txBody>
@@ -967,7 +1037,7 @@
           <a:lstStyle/>
           <a:p>
             <a:r>
-              <a:t>The full page also maps rangeland. ASAP updates every ten days.</a:t>
+              <a:t>Each region’s total for the months so far this rain year, as a share of its 1991–2020 normal.</a:t>
             </a:r>
           </a:p>
         </p:txBody>
@@ -1037,7 +1107,7 @@
           <a:lstStyle/>
           <a:p>
             <a:r>
-              <a:t>Satellite heights above the EGM2008 geoid, not the operator’s gauge datum: compare falls, not levels.</a:t>
+              <a:t>The full page also maps rangeland. ASAP updates every ten days.</a:t>
             </a:r>
           </a:p>
         </p:txBody>
@@ -1107,7 +1177,7 @@
           <a:lstStyle/>
           <a:p>
             <a:r>
-              <a:t>The October forecasts in 1997 and 2015 ranked about as dry; the rain that followed was among the driest on record in 1997 and below normal in 2015. February–April leans wet in the west and centre, where the forecast has low skill or the months fall outside the rainy season.</a:t>
+              <a:t>Satellite heights above the EGM2008 geoid, not the operator’s gauge datum: compare falls, not levels.</a:t>
             </a:r>
           </a:p>
         </p:txBody>
@@ -1177,7 +1247,7 @@
           <a:lstStyle/>
           <a:p>
             <a:r>
-              <a:t>Calendar: https://fews.net/latin-america-and-caribbean/venezuela</a:t>
+              <a:t>The October forecasts in 1997 and 2015 ranked about as dry; the rain that followed was among the driest on record in 1997 and below normal in 2015. February–April leans wet in the west and centre, where the forecast has low skill or the months fall outside the rainy season.</a:t>
             </a:r>
           </a:p>
         </p:txBody>
@@ -1247,7 +1317,7 @@
           <a:lstStyle/>
           <a:p>
             <a:r>
-              <a:t>Things that will change this picture over the coming weeks.</a:t>
+              <a:t>Calendar: https://fews.net/latin-america-and-caribbean/venezuela</a:t>
             </a:r>
           </a:p>
         </p:txBody>
@@ -1301,8 +1371,8 @@
         </p:nvSpPr>
         <p:spPr>
           <a:xfrm>
-            <a:off x="914377" y="2130425"/>
-            <a:ext cx="10362940" cy="1470025"/>
+            <a:off x="914400" y="2130425"/>
+            <a:ext cx="10363200" cy="1470025"/>
           </a:xfrm>
         </p:spPr>
         <p:txBody>
@@ -1329,8 +1399,8 @@
         </p:nvSpPr>
         <p:spPr>
           <a:xfrm>
-            <a:off x="1828754" y="3886200"/>
-            <a:ext cx="8534186" cy="1752600"/>
+            <a:off x="1828800" y="3886200"/>
+            <a:ext cx="8534400" cy="1752600"/>
           </a:xfrm>
         </p:spPr>
         <p:txBody>
@@ -1713,8 +1783,8 @@
         </p:nvSpPr>
         <p:spPr>
           <a:xfrm>
-            <a:off x="8838979" y="274638"/>
-            <a:ext cx="2743131" cy="5851525"/>
+            <a:off x="8839200" y="274638"/>
+            <a:ext cx="2743200" cy="5851525"/>
           </a:xfrm>
         </p:spPr>
         <p:txBody>
@@ -1741,8 +1811,8 @@
         </p:nvSpPr>
         <p:spPr>
           <a:xfrm>
-            <a:off x="609584" y="274638"/>
-            <a:ext cx="8026199" cy="5851525"/>
+            <a:off x="609600" y="274638"/>
+            <a:ext cx="8026400" cy="5851525"/>
           </a:xfrm>
         </p:spPr>
         <p:txBody>
@@ -2063,8 +2133,8 @@
         </p:nvSpPr>
         <p:spPr>
           <a:xfrm>
-            <a:off x="963059" y="4406900"/>
-            <a:ext cx="10362940" cy="1362075"/>
+            <a:off x="963084" y="4406900"/>
+            <a:ext cx="10363200" cy="1362075"/>
           </a:xfrm>
         </p:spPr>
         <p:txBody>
@@ -2095,8 +2165,8 @@
         </p:nvSpPr>
         <p:spPr>
           <a:xfrm>
-            <a:off x="963059" y="2906713"/>
-            <a:ext cx="10362940" cy="1500187"/>
+            <a:off x="963084" y="2906713"/>
+            <a:ext cx="10363200" cy="1500187"/>
           </a:xfrm>
         </p:spPr>
         <p:txBody>
@@ -2332,8 +2402,8 @@
         </p:nvSpPr>
         <p:spPr>
           <a:xfrm>
-            <a:off x="609584" y="1600200"/>
-            <a:ext cx="5384665" cy="4525963"/>
+            <a:off x="609600" y="1600200"/>
+            <a:ext cx="5384800" cy="4525963"/>
           </a:xfrm>
         </p:spPr>
         <p:txBody>
@@ -2417,8 +2487,8 @@
         </p:nvSpPr>
         <p:spPr>
           <a:xfrm>
-            <a:off x="6197445" y="1600200"/>
-            <a:ext cx="5384665" cy="4525963"/>
+            <a:off x="6197600" y="1600200"/>
+            <a:ext cx="5384800" cy="4525963"/>
           </a:xfrm>
         </p:spPr>
         <p:txBody>
@@ -2624,8 +2694,8 @@
         </p:nvSpPr>
         <p:spPr>
           <a:xfrm>
-            <a:off x="609584" y="1535113"/>
-            <a:ext cx="5386782" cy="639762"/>
+            <a:off x="609600" y="1535113"/>
+            <a:ext cx="5386917" cy="639762"/>
           </a:xfrm>
         </p:spPr>
         <p:txBody>
@@ -2689,8 +2759,8 @@
         </p:nvSpPr>
         <p:spPr>
           <a:xfrm>
-            <a:off x="609584" y="2174875"/>
-            <a:ext cx="5386782" cy="3951288"/>
+            <a:off x="609600" y="2174875"/>
+            <a:ext cx="5386917" cy="3951288"/>
           </a:xfrm>
         </p:spPr>
         <p:txBody>
@@ -2774,8 +2844,8 @@
         </p:nvSpPr>
         <p:spPr>
           <a:xfrm>
-            <a:off x="6193211" y="1535113"/>
-            <a:ext cx="5388898" cy="639762"/>
+            <a:off x="6193366" y="1535113"/>
+            <a:ext cx="5389033" cy="639762"/>
           </a:xfrm>
         </p:spPr>
         <p:txBody>
@@ -2839,8 +2909,8 @@
         </p:nvSpPr>
         <p:spPr>
           <a:xfrm>
-            <a:off x="6193211" y="2174875"/>
-            <a:ext cx="5388898" cy="3951288"/>
+            <a:off x="6193366" y="2174875"/>
+            <a:ext cx="5389033" cy="3951288"/>
           </a:xfrm>
         </p:spPr>
         <p:txBody>
@@ -3232,8 +3302,8 @@
         </p:nvSpPr>
         <p:spPr>
           <a:xfrm>
-            <a:off x="609584" y="273050"/>
-            <a:ext cx="4010983" cy="1162050"/>
+            <a:off x="609600" y="273050"/>
+            <a:ext cx="4011084" cy="1162050"/>
           </a:xfrm>
         </p:spPr>
         <p:txBody>
@@ -3264,8 +3334,8 @@
         </p:nvSpPr>
         <p:spPr>
           <a:xfrm>
-            <a:off x="4766614" y="273050"/>
-            <a:ext cx="6815496" cy="5853113"/>
+            <a:off x="4766733" y="273050"/>
+            <a:ext cx="6815666" cy="5853113"/>
           </a:xfrm>
         </p:spPr>
         <p:txBody>
@@ -3349,8 +3419,8 @@
         </p:nvSpPr>
         <p:spPr>
           <a:xfrm>
-            <a:off x="609584" y="1435100"/>
-            <a:ext cx="4010983" cy="4691063"/>
+            <a:off x="609600" y="1435100"/>
+            <a:ext cx="4011084" cy="4691063"/>
           </a:xfrm>
         </p:spPr>
         <p:txBody>
@@ -3509,8 +3579,8 @@
         </p:nvSpPr>
         <p:spPr>
           <a:xfrm>
-            <a:off x="2389657" y="4800600"/>
-            <a:ext cx="7315017" cy="566738"/>
+            <a:off x="2389717" y="4800600"/>
+            <a:ext cx="7315200" cy="566738"/>
           </a:xfrm>
         </p:spPr>
         <p:txBody>
@@ -3541,8 +3611,8 @@
         </p:nvSpPr>
         <p:spPr>
           <a:xfrm>
-            <a:off x="2389657" y="612775"/>
-            <a:ext cx="7315017" cy="4114800"/>
+            <a:off x="2389717" y="612775"/>
+            <a:ext cx="7315200" cy="4114800"/>
           </a:xfrm>
         </p:spPr>
         <p:txBody>
@@ -3602,8 +3672,8 @@
         </p:nvSpPr>
         <p:spPr>
           <a:xfrm>
-            <a:off x="2389657" y="5367338"/>
-            <a:ext cx="7315017" cy="804862"/>
+            <a:off x="2389717" y="5367338"/>
+            <a:ext cx="7315200" cy="804862"/>
           </a:xfrm>
         </p:spPr>
         <p:txBody>
@@ -3737,9 +3807,12 @@
 <p:sldMaster xmlns:a="http://schemas.openxmlformats.org/drawingml/2006/main" xmlns:r="http://schemas.openxmlformats.org/officeDocument/2006/relationships" xmlns:p="http://schemas.openxmlformats.org/presentationml/2006/main">
   <p:cSld>
     <p:bg>
-      <p:bgRef idx="1001">
-        <a:schemeClr val="bg1"/>
-      </p:bgRef>
+      <p:bgPr>
+        <a:solidFill>
+          <a:srgbClr val="FBF8F4"/>
+        </a:solidFill>
+        <a:effectLst/>
+      </p:bgPr>
     </p:bg>
     <p:spTree>
       <p:nvGrpSpPr>
@@ -3767,15 +3840,15 @@
         </p:nvSpPr>
         <p:spPr>
           <a:xfrm>
-            <a:off x="609584" y="274638"/>
-            <a:ext cx="10972525" cy="1143000"/>
+            <a:off x="548640" y="685800"/>
+            <a:ext cx="11064240" cy="1051560"/>
           </a:xfrm>
           <a:prstGeom prst="rect">
             <a:avLst/>
           </a:prstGeom>
         </p:spPr>
         <p:txBody>
-          <a:bodyPr vert="horz" lIns="91440" tIns="45720" rIns="91440" bIns="45720" rtlCol="0" anchor="ctr">
+          <a:bodyPr vert="horz" lIns="91440" tIns="45720" rIns="91440" bIns="45720" rtlCol="0" anchor="t">
             <a:normAutofit/>
           </a:bodyPr>
           <a:lstStyle/>
@@ -3800,8 +3873,8 @@
         </p:nvSpPr>
         <p:spPr>
           <a:xfrm>
-            <a:off x="609584" y="1600200"/>
-            <a:ext cx="10972525" cy="4525963"/>
+            <a:off x="609600" y="1600200"/>
+            <a:ext cx="10972800" cy="4525963"/>
           </a:xfrm>
           <a:prstGeom prst="rect">
             <a:avLst/>
@@ -3862,8 +3935,8 @@
         </p:nvSpPr>
         <p:spPr>
           <a:xfrm>
-            <a:off x="609584" y="6356350"/>
-            <a:ext cx="2844728" cy="365125"/>
+            <a:off x="609600" y="6356350"/>
+            <a:ext cx="2844800" cy="365125"/>
           </a:xfrm>
           <a:prstGeom prst="rect">
             <a:avLst/>
@@ -3903,8 +3976,8 @@
         </p:nvSpPr>
         <p:spPr>
           <a:xfrm>
-            <a:off x="4165495" y="6356350"/>
-            <a:ext cx="3860703" cy="365125"/>
+            <a:off x="4165600" y="6356350"/>
+            <a:ext cx="3860800" cy="365125"/>
           </a:xfrm>
           <a:prstGeom prst="rect">
             <a:avLst/>
@@ -3940,8 +4013,8 @@
         </p:nvSpPr>
         <p:spPr>
           <a:xfrm>
-            <a:off x="8737381" y="6356350"/>
-            <a:ext cx="2844728" cy="365125"/>
+            <a:off x="8737600" y="6356350"/>
+            <a:ext cx="2844800" cy="365125"/>
           </a:xfrm>
           <a:prstGeom prst="rect">
             <a:avLst/>
@@ -4406,7 +4479,9 @@
           </a:xfrm>
         </p:spPr>
         <p:txBody>
-          <a:bodyPr anchor="t" wrap="square"/>
+          <a:bodyPr anchor="t" wrap="square">
+            <a:normAutofit/>
+          </a:bodyPr>
           <a:lstStyle/>
           <a:p>
             <a:r>
@@ -4594,7 +4669,9 @@
           </a:xfrm>
         </p:spPr>
         <p:txBody>
-          <a:bodyPr anchor="t" wrap="square"/>
+          <a:bodyPr anchor="t" wrap="square">
+            <a:normAutofit/>
+          </a:bodyPr>
           <a:lstStyle/>
           <a:p>
             <a:r>
@@ -5125,7 +5202,9 @@
           </a:xfrm>
         </p:spPr>
         <p:txBody>
-          <a:bodyPr anchor="t" wrap="square"/>
+          <a:bodyPr anchor="t" wrap="square">
+            <a:normAutofit/>
+          </a:bodyPr>
           <a:lstStyle/>
           <a:p>
             <a:r>
@@ -5434,7 +5513,9 @@
           </a:xfrm>
         </p:spPr>
         <p:txBody>
-          <a:bodyPr anchor="t" wrap="square"/>
+          <a:bodyPr anchor="t" wrap="square">
+            <a:normAutofit/>
+          </a:bodyPr>
           <a:lstStyle/>
           <a:p>
             <a:r>
@@ -5927,7 +6008,9 @@
           </a:xfrm>
         </p:spPr>
         <p:txBody>
-          <a:bodyPr anchor="t" wrap="square"/>
+          <a:bodyPr anchor="t" wrap="square">
+            <a:normAutofit/>
+          </a:bodyPr>
           <a:lstStyle/>
           <a:p>
             <a:r>
@@ -6078,7 +6161,9 @@
           </a:xfrm>
         </p:spPr>
         <p:txBody>
-          <a:bodyPr anchor="t" wrap="square"/>
+          <a:bodyPr anchor="t" wrap="square">
+            <a:normAutofit/>
+          </a:bodyPr>
           <a:lstStyle/>
           <a:p>
             <a:r>
@@ -6290,7 +6375,9 @@
           </a:xfrm>
         </p:spPr>
         <p:txBody>
-          <a:bodyPr anchor="t" wrap="square"/>
+          <a:bodyPr anchor="t" wrap="square">
+            <a:normAutofit/>
+          </a:bodyPr>
           <a:lstStyle/>
           <a:p>
             <a:r>
@@ -6447,7 +6534,9 @@
           </a:xfrm>
         </p:spPr>
         <p:txBody>
-          <a:bodyPr anchor="t" wrap="square"/>
+          <a:bodyPr anchor="t" wrap="square">
+            <a:normAutofit/>
+          </a:bodyPr>
           <a:lstStyle/>
           <a:p>
             <a:r>
@@ -6456,7 +6545,7 @@
                   <a:srgbClr val="1F2328"/>
                 </a:solidFill>
               </a:rPr>
-              <a:t>SEAS5 forecasts one of the driest October–February periods since 1981, wherever it is the rainy season</a:t>
+              <a:t>SEAS5, October 2026: one of the driest October–February forecasts since 1981, wherever it is the rainy season</a:t>
             </a:r>
           </a:p>
         </p:txBody>
@@ -6554,7 +6643,7 @@
         <p:spPr>
           <a:xfrm>
             <a:off x="457200" y="2103120"/>
-            <a:ext cx="7772400" cy="3146933"/>
+            <a:ext cx="7772400" cy="2891452"/>
           </a:xfrm>
           <a:prstGeom prst="rect">
             <a:avLst/>
@@ -6675,7 +6764,9 @@
           </a:xfrm>
         </p:spPr>
         <p:txBody>
-          <a:bodyPr anchor="t" wrap="square"/>
+          <a:bodyPr anchor="t" wrap="square">
+            <a:normAutofit/>
+          </a:bodyPr>
           <a:lstStyle/>
           <a:p>
             <a:r>

</xml_diff>